<commit_message>
Deploy: move railway.json to repo root so Railway finds it; allow *.vercel.app CORS
</commit_message>
<xml_diff>
--- a/docs/Fleet-Copilot-Deck.pptx
+++ b/docs/Fleet-Copilot-Deck.pptx
@@ -4,6 +4,9 @@
   <p:sldMasterIdLst>
     <p:sldMasterId id="2147483648" r:id="rId1"/>
   </p:sldMasterIdLst>
+  <p:notesMasterIdLst>
+    <p:notesMasterId r:id="rId12"/>
+  </p:notesMasterIdLst>
   <p:sldIdLst>
     <p:sldId id="256" r:id="rId2"/>
     <p:sldId id="257" r:id="rId3"/>
@@ -16,9 +19,6 @@
     <p:sldId id="264" r:id="rId10"/>
     <p:sldId id="265" r:id="rId11"/>
   </p:sldIdLst>
-  <p:notesMasterIdLst>
-    <p:notesMasterId r:id="rId12"/>
-  </p:notesMasterIdLst>
   <p:sldSz cx="12192000" cy="6858000"/>
   <p:notesSz cx="6858000" cy="12192000"/>
   <p:defaultTextStyle>
@@ -113,6 +113,11 @@
       </a:defRPr>
     </a:lvl9pPr>
   </p:defaultTextStyle>
+  <p:extLst>
+    <p:ext uri="{EFAFB233-063F-42B5-8137-9DF3F51BA10A}">
+      <p15:sldGuideLst xmlns:p15="http://schemas.microsoft.com/office/powerpoint/2012/main"/>
+    </p:ext>
+  </p:extLst>
 </p:presentation>
 </file>
 
@@ -138,234 +143,10 @@
           <a:chExt cx="0" cy="0"/>
         </a:xfrm>
       </p:grpSpPr>
-      <p:sp>
-        <p:nvSpPr>
-          <p:cNvPr id="2" name="Header Placeholder 1"/>
-          <p:cNvSpPr>
-            <a:spLocks noGrp="1"/>
-          </p:cNvSpPr>
-          <p:nvPr>
-            <p:ph type="hdr" sz="quarter"/>
-          </p:nvPr>
-        </p:nvSpPr>
-        <p:spPr>
-          <a:xfrm>
-            <a:off x="0" y="0"/>
-            <a:ext cx="2971800" cy="458788"/>
-          </a:xfrm>
-          <a:prstGeom prst="rect">
-            <a:avLst/>
-          </a:prstGeom>
-        </p:spPr>
-        <p:txBody>
-          <a:bodyPr vert="horz" lIns="91440" tIns="45720" rIns="91440" bIns="45720" rtlCol="0"/>
-          <a:lstStyle>
-            <a:lvl1pPr algn="l">
-              <a:defRPr sz="1200"/>
-            </a:lvl1pPr>
-          </a:lstStyle>
-          <a:p>
-            <a:endParaRPr lang="en-US"/>
-          </a:p>
-        </p:txBody>
-      </p:sp>
-      <p:sp>
-        <p:nvSpPr>
-          <p:cNvPr id="3" name="Date Placeholder 2"/>
-          <p:cNvSpPr>
-            <a:spLocks noGrp="1"/>
-          </p:cNvSpPr>
-          <p:nvPr>
-            <p:ph type="dt" idx="1"/>
-          </p:nvPr>
-        </p:nvSpPr>
-        <p:spPr>
-          <a:xfrm>
-            <a:off x="3884613" y="0"/>
-            <a:ext cx="2971800" cy="458788"/>
-          </a:xfrm>
-          <a:prstGeom prst="rect">
-            <a:avLst/>
-          </a:prstGeom>
-        </p:spPr>
-        <p:txBody>
-          <a:bodyPr vert="horz" lIns="91440" tIns="45720" rIns="91440" bIns="45720" rtlCol="0"/>
-          <a:lstStyle>
-            <a:lvl1pPr algn="r">
-              <a:defRPr sz="1200"/>
-            </a:lvl1pPr>
-          </a:lstStyle>
-          <a:p>
-            <a:fld id="{5282F153-3F37-0F45-9E97-73ACFA13230C}" type="datetimeFigureOut">
-              <a:rPr lang="en-US"/>
-              <a:t>7/23/19</a:t>
-            </a:fld>
-            <a:endParaRPr lang="en-US"/>
-          </a:p>
-        </p:txBody>
-      </p:sp>
-      <p:sp>
-        <p:nvSpPr>
-          <p:cNvPr id="4" name="Slide Image Placeholder 3"/>
-          <p:cNvSpPr>
-            <a:spLocks noGrp="1" noRot="1" noChangeAspect="1"/>
-          </p:cNvSpPr>
-          <p:nvPr>
-            <p:ph type="sldImg" idx="2"/>
-          </p:nvPr>
-        </p:nvSpPr>
-        <p:spPr>
-          <a:xfrm>
-            <a:off x="685800" y="1143000"/>
-            <a:ext cx="5486400" cy="3086100"/>
-          </a:xfrm>
-          <a:prstGeom prst="rect">
-            <a:avLst/>
-          </a:prstGeom>
-          <a:noFill/>
-          <a:ln w="12700">
-            <a:solidFill>
-              <a:prstClr val="black"/>
-            </a:solidFill>
-          </a:ln>
-        </p:spPr>
-        <p:txBody>
-          <a:bodyPr vert="horz" lIns="91440" tIns="45720" rIns="91440" bIns="45720" rtlCol="0" anchor="ctr"/>
-          <a:lstStyle/>
-          <a:p>
-            <a:endParaRPr lang="en-US"/>
-          </a:p>
-        </p:txBody>
-      </p:sp>
-      <p:sp>
-        <p:nvSpPr>
-          <p:cNvPr id="5" name="Notes Placeholder 4"/>
-          <p:cNvSpPr>
-            <a:spLocks noGrp="1"/>
-          </p:cNvSpPr>
-          <p:nvPr>
-            <p:ph type="body" sz="quarter" idx="3"/>
-          </p:nvPr>
-        </p:nvSpPr>
-        <p:spPr>
-          <a:xfrm>
-            <a:off x="685800" y="4400550"/>
-            <a:ext cx="5486400" cy="3600450"/>
-          </a:xfrm>
-          <a:prstGeom prst="rect">
-            <a:avLst/>
-          </a:prstGeom>
-        </p:spPr>
-        <p:txBody>
-          <a:bodyPr vert="horz" lIns="91440" tIns="45720" rIns="91440" bIns="45720" rtlCol="0"/>
-          <a:lstStyle/>
-          <a:p>
-            <a:pPr lvl="0"/>
-            <a:r>
-              <a:rPr lang="en-US"/>
-              <a:t>Click to edit Master text styles</a:t>
-            </a:r>
-          </a:p>
-          <a:p>
-            <a:pPr lvl="1"/>
-            <a:r>
-              <a:rPr lang="en-US"/>
-              <a:t>Second level</a:t>
-            </a:r>
-          </a:p>
-          <a:p>
-            <a:pPr lvl="2"/>
-            <a:r>
-              <a:rPr lang="en-US"/>
-              <a:t>Third level</a:t>
-            </a:r>
-          </a:p>
-          <a:p>
-            <a:pPr lvl="3"/>
-            <a:r>
-              <a:rPr lang="en-US"/>
-              <a:t>Fourth level</a:t>
-            </a:r>
-          </a:p>
-          <a:p>
-            <a:pPr lvl="4"/>
-            <a:r>
-              <a:rPr lang="en-US"/>
-              <a:t>Fifth level</a:t>
-            </a:r>
-          </a:p>
-        </p:txBody>
-      </p:sp>
-      <p:sp>
-        <p:nvSpPr>
-          <p:cNvPr id="6" name="Footer Placeholder 5"/>
-          <p:cNvSpPr>
-            <a:spLocks noGrp="1"/>
-          </p:cNvSpPr>
-          <p:nvPr>
-            <p:ph type="ftr" sz="quarter" idx="4"/>
-          </p:nvPr>
-        </p:nvSpPr>
-        <p:spPr>
-          <a:xfrm>
-            <a:off x="0" y="8685213"/>
-            <a:ext cx="2971800" cy="458787"/>
-          </a:xfrm>
-          <a:prstGeom prst="rect">
-            <a:avLst/>
-          </a:prstGeom>
-        </p:spPr>
-        <p:txBody>
-          <a:bodyPr vert="horz" lIns="91440" tIns="45720" rIns="91440" bIns="45720" rtlCol="0" anchor="b"/>
-          <a:lstStyle>
-            <a:lvl1pPr algn="l">
-              <a:defRPr sz="1200"/>
-            </a:lvl1pPr>
-          </a:lstStyle>
-          <a:p>
-            <a:endParaRPr lang="en-US"/>
-          </a:p>
-        </p:txBody>
-      </p:sp>
-      <p:sp>
-        <p:nvSpPr>
-          <p:cNvPr id="7" name="Slide Number Placeholder 6"/>
-          <p:cNvSpPr>
-            <a:spLocks noGrp="1"/>
-          </p:cNvSpPr>
-          <p:nvPr>
-            <p:ph type="sldNum" sz="quarter" idx="5"/>
-          </p:nvPr>
-        </p:nvSpPr>
-        <p:spPr>
-          <a:xfrm>
-            <a:off x="3884613" y="8685213"/>
-            <a:ext cx="2971800" cy="458787"/>
-          </a:xfrm>
-          <a:prstGeom prst="rect">
-            <a:avLst/>
-          </a:prstGeom>
-        </p:spPr>
-        <p:txBody>
-          <a:bodyPr vert="horz" lIns="91440" tIns="45720" rIns="91440" bIns="45720" rtlCol="0" anchor="b"/>
-          <a:lstStyle>
-            <a:lvl1pPr algn="r">
-              <a:defRPr sz="1200"/>
-            </a:lvl1pPr>
-          </a:lstStyle>
-          <a:p>
-            <a:fld id="{CE5E9CC1-C706-0F49-92D6-E571CC5EEA8F}" type="slidenum">
-              <a:rPr lang="en-US"/>
-              <a:t>‹#›</a:t>
-            </a:fld>
-            <a:endParaRPr lang="en-US"/>
-          </a:p>
-        </p:txBody>
-      </p:sp>
     </p:spTree>
     <p:extLst>
       <p:ext uri="{BB962C8B-B14F-4D97-AF65-F5344CB8AC3E}">
-        <p14:creationId xmlns:p14="http://schemas.microsoft.com/office/powerpoint/2010/main" val="1024086991"/>
+        <p14:creationId xmlns:p14="http://schemas.microsoft.com/office/powerpoint/2010/main" val="393074283"/>
       </p:ext>
     </p:extLst>
   </p:cSld>
@@ -509,10 +290,6 @@
           <a:bodyPr/>
           <a:lstStyle/>
           <a:p>
-            <a:r>
-              <a:rPr lang="en-US" dirty="0"/>
-              <a:t/>
-            </a:r>
             <a:endParaRPr lang="en-US" dirty="0"/>
           </a:p>
         </p:txBody>
@@ -597,10 +374,6 @@
           <a:bodyPr/>
           <a:lstStyle/>
           <a:p>
-            <a:r>
-              <a:rPr lang="en-US" dirty="0"/>
-              <a:t/>
-            </a:r>
             <a:endParaRPr lang="en-US" dirty="0"/>
           </a:p>
         </p:txBody>
@@ -685,10 +458,6 @@
           <a:bodyPr/>
           <a:lstStyle/>
           <a:p>
-            <a:r>
-              <a:rPr lang="en-US" dirty="0"/>
-              <a:t/>
-            </a:r>
             <a:endParaRPr lang="en-US" dirty="0"/>
           </a:p>
         </p:txBody>
@@ -773,10 +542,6 @@
           <a:bodyPr/>
           <a:lstStyle/>
           <a:p>
-            <a:r>
-              <a:rPr lang="en-US" dirty="0"/>
-              <a:t/>
-            </a:r>
             <a:endParaRPr lang="en-US" dirty="0"/>
           </a:p>
         </p:txBody>
@@ -861,10 +626,6 @@
           <a:bodyPr/>
           <a:lstStyle/>
           <a:p>
-            <a:r>
-              <a:rPr lang="en-US" dirty="0"/>
-              <a:t/>
-            </a:r>
             <a:endParaRPr lang="en-US" dirty="0"/>
           </a:p>
         </p:txBody>
@@ -949,10 +710,6 @@
           <a:bodyPr/>
           <a:lstStyle/>
           <a:p>
-            <a:r>
-              <a:rPr lang="en-US" dirty="0"/>
-              <a:t/>
-            </a:r>
             <a:endParaRPr lang="en-US" dirty="0"/>
           </a:p>
         </p:txBody>
@@ -1037,10 +794,6 @@
           <a:bodyPr/>
           <a:lstStyle/>
           <a:p>
-            <a:r>
-              <a:rPr lang="en-US" dirty="0"/>
-              <a:t/>
-            </a:r>
             <a:endParaRPr lang="en-US" dirty="0"/>
           </a:p>
         </p:txBody>
@@ -1125,10 +878,6 @@
           <a:bodyPr/>
           <a:lstStyle/>
           <a:p>
-            <a:r>
-              <a:rPr lang="en-US" dirty="0"/>
-              <a:t/>
-            </a:r>
             <a:endParaRPr lang="en-US" dirty="0"/>
           </a:p>
         </p:txBody>
@@ -1213,10 +962,6 @@
           <a:bodyPr/>
           <a:lstStyle/>
           <a:p>
-            <a:r>
-              <a:rPr lang="en-US" dirty="0"/>
-              <a:t/>
-            </a:r>
             <a:endParaRPr lang="en-US" dirty="0"/>
           </a:p>
         </p:txBody>
@@ -1301,10 +1046,6 @@
           <a:bodyPr/>
           <a:lstStyle/>
           <a:p>
-            <a:r>
-              <a:rPr lang="en-US" dirty="0"/>
-              <a:t/>
-            </a:r>
             <a:endParaRPr lang="en-US" dirty="0"/>
           </a:p>
         </p:txBody>
@@ -1378,6 +1119,11 @@
 <file path=ppt/slideMasters/slideMaster1.xml><?xml version="1.0" encoding="utf-8"?>
 <p:sldMaster xmlns:a="http://schemas.openxmlformats.org/drawingml/2006/main" xmlns:r="http://schemas.openxmlformats.org/officeDocument/2006/relationships" xmlns:p="http://schemas.openxmlformats.org/presentationml/2006/main">
   <p:cSld>
+    <p:bg>
+      <p:bgRef idx="1001">
+        <a:schemeClr val="bg1"/>
+      </p:bgRef>
+    </p:bg>
     <p:spTree>
       <p:nvGrpSpPr>
         <p:cNvPr id="1" name=""/>
@@ -1660,6 +1406,7 @@
         <a:solidFill>
           <a:srgbClr val="10151D"/>
         </a:solidFill>
+        <a:effectLst/>
       </p:bgPr>
     </p:bg>
     <p:spTree>
@@ -1697,11 +1444,11 @@
           <a:bodyPr wrap="square" lIns="0" tIns="0" rIns="0" bIns="0" rtlCol="0" anchor="ctr"/>
           <a:lstStyle/>
           <a:p>
-            <a:pPr indent="0" marL="0">
-              <a:buNone/>
-            </a:pPr>
-            <a:r>
-              <a:rPr lang="en-US" sz="1300" b="1" spc="300" kern="0" dirty="0">
+            <a:pPr marL="0" indent="0">
+              <a:buNone/>
+            </a:pPr>
+            <a:r>
+              <a:rPr lang="en-US" sz="1300" b="1" kern="0" spc="300" dirty="0">
                 <a:solidFill>
                   <a:srgbClr val="2489E9"/>
                 </a:solidFill>
@@ -1736,7 +1483,7 @@
           <a:bodyPr wrap="square" lIns="0" tIns="0" rIns="0" bIns="0" rtlCol="0" anchor="ctr"/>
           <a:lstStyle/>
           <a:p>
-            <a:pPr indent="0" marL="0">
+            <a:pPr marL="0" indent="0">
               <a:buNone/>
             </a:pPr>
             <a:r>
@@ -1775,7 +1522,7 @@
           <a:bodyPr wrap="square" lIns="0" tIns="0" rIns="0" bIns="0" rtlCol="0" anchor="ctr"/>
           <a:lstStyle/>
           <a:p>
-            <a:pPr indent="0" marL="0">
+            <a:pPr marL="0" indent="0">
               <a:lnSpc>
                 <a:spcPct val="115000"/>
               </a:lnSpc>
@@ -1790,7 +1537,7 @@
                 <a:ea typeface="Calibri" pitchFamily="34" charset="-122"/>
                 <a:cs typeface="Calibri" pitchFamily="34" charset="-120"/>
               </a:rPr>
-              <a:t>An AI-native operations assistant for 5–50 truck fleets — it watches every load, investigates its own alarms, and hands the dispatcher decisions instead of dashboards.</a:t>
+              <a:t>An AI-native operations assistant for 5-50 truck fleets - it watches every load, investigates its own alarms, and hands the dispatcher decisions instead of dashboards.</a:t>
             </a:r>
             <a:endParaRPr lang="en-US" sz="1700" dirty="0"/>
           </a:p>
@@ -1817,7 +1564,7 @@
           <a:bodyPr wrap="square" lIns="0" tIns="0" rIns="0" bIns="0" rtlCol="0" anchor="ctr"/>
           <a:lstStyle/>
           <a:p>
-            <a:pPr indent="0" marL="0">
+            <a:pPr marL="0" indent="0">
               <a:buNone/>
             </a:pPr>
             <a:r>
@@ -1851,6 +1598,7 @@
         <a:solidFill>
           <a:srgbClr val="10151D"/>
         </a:solidFill>
+        <a:effectLst/>
       </p:bgPr>
     </p:bg>
     <p:spTree>
@@ -1888,11 +1636,11 @@
           <a:bodyPr wrap="square" lIns="0" tIns="0" rIns="0" bIns="0" rtlCol="0" anchor="ctr"/>
           <a:lstStyle/>
           <a:p>
-            <a:pPr indent="0" marL="0">
-              <a:buNone/>
-            </a:pPr>
-            <a:r>
-              <a:rPr lang="en-US" sz="1200" b="1" spc="300" kern="0" dirty="0">
+            <a:pPr marL="0" indent="0">
+              <a:buNone/>
+            </a:pPr>
+            <a:r>
+              <a:rPr lang="en-US" sz="1200" b="1" kern="0" spc="300" dirty="0">
                 <a:solidFill>
                   <a:srgbClr val="2489E9"/>
                 </a:solidFill>
@@ -1927,7 +1675,7 @@
           <a:bodyPr wrap="square" lIns="0" tIns="0" rIns="0" bIns="0" rtlCol="0" anchor="ctr"/>
           <a:lstStyle/>
           <a:p>
-            <a:pPr indent="0" marL="0">
+            <a:pPr marL="0" indent="0">
               <a:buNone/>
             </a:pPr>
             <a:r>
@@ -1966,7 +1714,7 @@
           <a:bodyPr wrap="square" lIns="0" tIns="0" rIns="0" bIns="0" rtlCol="0" anchor="ctr"/>
           <a:lstStyle/>
           <a:p>
-            <a:pPr indent="0" marL="0">
+            <a:pPr marL="0" indent="0">
               <a:buNone/>
             </a:pPr>
             <a:r>
@@ -2005,7 +1753,7 @@
           <a:bodyPr wrap="square" lIns="0" tIns="0" rIns="0" bIns="0" rtlCol="0" anchor="t"/>
           <a:lstStyle/>
           <a:p>
-            <a:pPr indent="0" marL="0">
+            <a:pPr marL="0" indent="0">
               <a:lnSpc>
                 <a:spcPct val="115000"/>
               </a:lnSpc>
@@ -2020,7 +1768,7 @@
                 <a:ea typeface="Calibri" pitchFamily="34" charset="-122"/>
                 <a:cs typeface="Calibri" pitchFamily="34" charset="-120"/>
               </a:rPr>
-              <a:t>Swap the sim for TP ELD / Command streams — the watchdog and agents don't change, only the ingest does. That's the point of the two-plane design.</a:t>
+              <a:t>Swap the sim for TP ELD / Command streams - the watchdog and agents don't change, only the ingest does. That's the point of the two-plane design.</a:t>
             </a:r>
             <a:endParaRPr lang="en-US" sz="1250" dirty="0"/>
           </a:p>
@@ -2047,7 +1795,7 @@
           <a:bodyPr wrap="square" lIns="0" tIns="0" rIns="0" bIns="0" rtlCol="0" anchor="ctr"/>
           <a:lstStyle/>
           <a:p>
-            <a:pPr indent="0" marL="0">
+            <a:pPr marL="0" indent="0">
               <a:buNone/>
             </a:pPr>
             <a:r>
@@ -2086,7 +1834,7 @@
           <a:bodyPr wrap="square" lIns="0" tIns="0" rIns="0" bIns="0" rtlCol="0" anchor="t"/>
           <a:lstStyle/>
           <a:p>
-            <a:pPr indent="0" marL="0">
+            <a:pPr marL="0" indent="0">
               <a:lnSpc>
                 <a:spcPct val="115000"/>
               </a:lnSpc>
@@ -2128,7 +1876,7 @@
           <a:bodyPr wrap="square" lIns="0" tIns="0" rIns="0" bIns="0" rtlCol="0" anchor="ctr"/>
           <a:lstStyle/>
           <a:p>
-            <a:pPr indent="0" marL="0">
+            <a:pPr marL="0" indent="0">
               <a:buNone/>
             </a:pPr>
             <a:r>
@@ -2167,7 +1915,7 @@
           <a:bodyPr wrap="square" lIns="0" tIns="0" rIns="0" bIns="0" rtlCol="0" anchor="t"/>
           <a:lstStyle/>
           <a:p>
-            <a:pPr indent="0" marL="0">
+            <a:pPr marL="0" indent="0">
               <a:lnSpc>
                 <a:spcPct val="115000"/>
               </a:lnSpc>
@@ -2182,7 +1930,7 @@
                 <a:ea typeface="Calibri" pitchFamily="34" charset="-122"/>
                 <a:cs typeface="Calibri" pitchFamily="34" charset="-120"/>
               </a:rPr>
-              <a:t>From one-load recommendations to board-level assignment — deadhead-aware matching across tomorrow's loads. The ripple-effect problem.</a:t>
+              <a:t>From one-load recommendations to board-level assignment - deadhead-aware matching across tomorrow's loads. The ripple-effect problem.</a:t>
             </a:r>
             <a:endParaRPr lang="en-US" sz="1250" dirty="0"/>
           </a:p>
@@ -2209,7 +1957,7 @@
           <a:bodyPr wrap="square" lIns="0" tIns="0" rIns="0" bIns="0" rtlCol="0" anchor="ctr"/>
           <a:lstStyle/>
           <a:p>
-            <a:pPr indent="0" marL="0">
+            <a:pPr marL="0" indent="0">
               <a:buNone/>
             </a:pPr>
             <a:r>
@@ -2221,7 +1969,7 @@
                 <a:ea typeface="Calibri" pitchFamily="34" charset="-122"/>
                 <a:cs typeface="Calibri" pitchFamily="34" charset="-120"/>
               </a:rPr>
-              <a:t>Thanks — the prototype is live; every agent decision you saw was a real model call.</a:t>
+              <a:t>Thank you - the prototype is live.</a:t>
             </a:r>
             <a:endParaRPr lang="en-US" sz="1150" dirty="0"/>
           </a:p>
@@ -2243,6 +1991,7 @@
         <a:solidFill>
           <a:srgbClr val="FFFFFF"/>
         </a:solidFill>
+        <a:effectLst/>
       </p:bgPr>
     </p:bg>
     <p:spTree>
@@ -2280,11 +2029,11 @@
           <a:bodyPr wrap="square" lIns="0" tIns="0" rIns="0" bIns="0" rtlCol="0" anchor="ctr"/>
           <a:lstStyle/>
           <a:p>
-            <a:pPr indent="0" marL="0">
-              <a:buNone/>
-            </a:pPr>
-            <a:r>
-              <a:rPr lang="en-US" sz="1200" b="1" spc="300" kern="0" dirty="0">
+            <a:pPr marL="0" indent="0">
+              <a:buNone/>
+            </a:pPr>
+            <a:r>
+              <a:rPr lang="en-US" sz="1200" b="1" kern="0" spc="300" dirty="0">
                 <a:solidFill>
                   <a:srgbClr val="2489E9"/>
                 </a:solidFill>
@@ -2319,7 +2068,7 @@
           <a:bodyPr wrap="square" lIns="0" tIns="0" rIns="0" bIns="0" rtlCol="0" anchor="ctr"/>
           <a:lstStyle/>
           <a:p>
-            <a:pPr indent="0" marL="0">
+            <a:pPr marL="0" indent="0">
               <a:buNone/>
             </a:pPr>
             <a:r>
@@ -2385,7 +2134,7 @@
           <a:bodyPr wrap="square" lIns="0" tIns="0" rIns="0" bIns="0" rtlCol="0" anchor="ctr"/>
           <a:lstStyle/>
           <a:p>
-            <a:pPr indent="0" marL="0">
+            <a:pPr marL="0" indent="0">
               <a:buNone/>
             </a:pPr>
             <a:r>
@@ -2424,7 +2173,7 @@
           <a:bodyPr wrap="square" lIns="0" tIns="0" rIns="0" bIns="0" rtlCol="0" anchor="t"/>
           <a:lstStyle/>
           <a:p>
-            <a:pPr indent="0" marL="0">
+            <a:pPr marL="0" indent="0">
               <a:lnSpc>
                 <a:spcPct val="112000"/>
               </a:lnSpc>
@@ -2439,7 +2188,7 @@
                 <a:ea typeface="Calibri" pitchFamily="34" charset="-122"/>
                 <a:cs typeface="Calibri" pitchFamily="34" charset="-120"/>
               </a:rPr>
-              <a:t>Three loads to cover. Who's closest? Who has hours left? Six phone calls to find out — and the answer changes while you dial.</a:t>
+              <a:t>Three loads to cover. Who's closest? Who has hours left? Six phone calls to find out - and the answer changes while you dial.</a:t>
             </a:r>
             <a:endParaRPr lang="en-US" sz="1150" dirty="0"/>
           </a:p>
@@ -2493,7 +2242,7 @@
           <a:bodyPr wrap="square" lIns="0" tIns="0" rIns="0" bIns="0" rtlCol="0" anchor="ctr"/>
           <a:lstStyle/>
           <a:p>
-            <a:pPr indent="0" marL="0">
+            <a:pPr marL="0" indent="0">
               <a:buNone/>
             </a:pPr>
             <a:r>
@@ -2532,7 +2281,7 @@
           <a:bodyPr wrap="square" lIns="0" tIns="0" rIns="0" bIns="0" rtlCol="0" anchor="t"/>
           <a:lstStyle/>
           <a:p>
-            <a:pPr indent="0" marL="0">
+            <a:pPr marL="0" indent="0">
               <a:lnSpc>
                 <a:spcPct val="112000"/>
               </a:lnSpc>
@@ -2547,7 +2296,7 @@
                 <a:ea typeface="Calibri" pitchFamily="34" charset="-122"/>
                 <a:cs typeface="Calibri" pitchFamily="34" charset="-120"/>
               </a:rPr>
-              <a:t>A load goes dark in Arkansas. You find out at 4 PM — when the customer calls you.</a:t>
+              <a:t>A load goes dark in Arkansas. You find out at 4 PM - when the customer calls you.</a:t>
             </a:r>
             <a:endParaRPr lang="en-US" sz="1150" dirty="0"/>
           </a:p>
@@ -2601,7 +2350,7 @@
           <a:bodyPr wrap="square" lIns="0" tIns="0" rIns="0" bIns="0" rtlCol="0" anchor="ctr"/>
           <a:lstStyle/>
           <a:p>
-            <a:pPr indent="0" marL="0">
+            <a:pPr marL="0" indent="0">
               <a:buNone/>
             </a:pPr>
             <a:r>
@@ -2640,7 +2389,7 @@
           <a:bodyPr wrap="square" lIns="0" tIns="0" rIns="0" bIns="0" rtlCol="0" anchor="t"/>
           <a:lstStyle/>
           <a:p>
-            <a:pPr indent="0" marL="0">
+            <a:pPr marL="0" indent="0">
               <a:lnSpc>
                 <a:spcPct val="112000"/>
               </a:lnSpc>
@@ -2709,7 +2458,7 @@
           <a:bodyPr wrap="square" lIns="0" tIns="0" rIns="0" bIns="0" rtlCol="0" anchor="ctr"/>
           <a:lstStyle/>
           <a:p>
-            <a:pPr indent="0" marL="0">
+            <a:pPr marL="0" indent="0">
               <a:buNone/>
             </a:pPr>
             <a:r>
@@ -2748,7 +2497,7 @@
           <a:bodyPr wrap="square" lIns="0" tIns="0" rIns="0" bIns="0" rtlCol="0" anchor="t"/>
           <a:lstStyle/>
           <a:p>
-            <a:pPr indent="0" marL="0">
+            <a:pPr marL="0" indent="0">
               <a:lnSpc>
                 <a:spcPct val="112000"/>
               </a:lnSpc>
@@ -2763,7 +2512,7 @@
                 <a:ea typeface="Calibri" pitchFamily="34" charset="-122"/>
                 <a:cs typeface="Calibri" pitchFamily="34" charset="-120"/>
               </a:rPr>
-              <a:t>Chasing drivers for PODs and receipts. Invoices go out 4–5 days late, detention goes unbilled, nobody notices until quarter end.</a:t>
+              <a:t>Chasing drivers for PODs and receipts. Invoices go out 4-5 days late, detention goes unbilled, nobody notices until quarter end.</a:t>
             </a:r>
             <a:endParaRPr lang="en-US" sz="1150" dirty="0"/>
           </a:p>
@@ -2785,6 +2534,7 @@
         <a:solidFill>
           <a:srgbClr val="FFFFFF"/>
         </a:solidFill>
+        <a:effectLst/>
       </p:bgPr>
     </p:bg>
     <p:spTree>
@@ -2822,11 +2572,11 @@
           <a:bodyPr wrap="square" lIns="0" tIns="0" rIns="0" bIns="0" rtlCol="0" anchor="ctr"/>
           <a:lstStyle/>
           <a:p>
-            <a:pPr indent="0" marL="0">
-              <a:buNone/>
-            </a:pPr>
-            <a:r>
-              <a:rPr lang="en-US" sz="1200" b="1" spc="300" kern="0" dirty="0">
+            <a:pPr marL="0" indent="0">
+              <a:buNone/>
+            </a:pPr>
+            <a:r>
+              <a:rPr lang="en-US" sz="1200" b="1" kern="0" spc="300" dirty="0">
                 <a:solidFill>
                   <a:srgbClr val="2489E9"/>
                 </a:solidFill>
@@ -2861,7 +2611,7 @@
           <a:bodyPr wrap="square" lIns="0" tIns="0" rIns="0" bIns="0" rtlCol="0" anchor="ctr"/>
           <a:lstStyle/>
           <a:p>
-            <a:pPr indent="0" marL="0">
+            <a:pPr marL="0" indent="0">
               <a:buNone/>
             </a:pPr>
             <a:r>
@@ -2878,7 +2628,7 @@
             <a:endParaRPr lang="en-US" sz="3200" dirty="0"/>
           </a:p>
           <a:p>
-            <a:pPr indent="0" marL="0">
+            <a:pPr marL="0" indent="0">
               <a:buNone/>
             </a:pPr>
             <a:r>
@@ -2944,7 +2694,7 @@
           <a:bodyPr wrap="square" lIns="0" tIns="0" rIns="0" bIns="0" rtlCol="0" anchor="ctr"/>
           <a:lstStyle/>
           <a:p>
-            <a:pPr indent="0" marL="0">
+            <a:pPr marL="0" indent="0">
               <a:buNone/>
             </a:pPr>
             <a:r>
@@ -2956,7 +2706,7 @@
                 <a:ea typeface="Arial" pitchFamily="34" charset="-122"/>
                 <a:cs typeface="Arial" pitchFamily="34" charset="-120"/>
               </a:rPr>
-              <a:t>SYSTEM OF RECORD — STATUS QUO</a:t>
+              <a:t>SYSTEM OF RECORD - STATUS QUO</a:t>
             </a:r>
             <a:endParaRPr lang="en-US" sz="1250" dirty="0"/>
           </a:p>
@@ -3116,7 +2866,7 @@
           <a:bodyPr wrap="square" lIns="0" tIns="0" rIns="0" bIns="0" rtlCol="0" anchor="ctr"/>
           <a:lstStyle/>
           <a:p>
-            <a:pPr indent="0" marL="0">
+            <a:pPr marL="0" indent="0">
               <a:buNone/>
             </a:pPr>
             <a:r>
@@ -3128,7 +2878,7 @@
                 <a:ea typeface="Arial" pitchFamily="34" charset="-122"/>
                 <a:cs typeface="Arial" pitchFamily="34" charset="-120"/>
               </a:rPr>
-              <a:t>SYSTEM OF AGENCY — FLEET COPILOT</a:t>
+              <a:t>SYSTEM OF AGENCY - FLEET COPILOT</a:t>
             </a:r>
             <a:endParaRPr lang="en-US" sz="1250" dirty="0"/>
           </a:p>
@@ -3234,48 +2984,9 @@
                 <a:ea typeface="Calibri" pitchFamily="34" charset="-122"/>
                 <a:cs typeface="Calibri" pitchFamily="34" charset="-120"/>
               </a:rPr>
-              <a:t>Human edits inline and approves — every action stays human-gated</a:t>
+              <a:t>Human edits inline and approves - every action stays human-gated</a:t>
             </a:r>
             <a:endParaRPr lang="en-US" sz="1250" dirty="0"/>
-          </a:p>
-        </p:txBody>
-      </p:sp>
-      <p:sp>
-        <p:nvSpPr>
-          <p:cNvPr id="10" name="Text 8"/>
-          <p:cNvSpPr/>
-          <p:nvPr/>
-        </p:nvSpPr>
-        <p:spPr>
-          <a:xfrm>
-            <a:off x="640080" y="6126480"/>
-            <a:ext cx="10881360" cy="365760"/>
-          </a:xfrm>
-          <a:prstGeom prst="rect">
-            <a:avLst/>
-          </a:prstGeom>
-          <a:noFill/>
-          <a:ln/>
-        </p:spPr>
-        <p:txBody>
-          <a:bodyPr wrap="square" lIns="0" tIns="0" rIns="0" bIns="0" rtlCol="0" anchor="ctr"/>
-          <a:lstStyle/>
-          <a:p>
-            <a:pPr indent="0" marL="0">
-              <a:buNone/>
-            </a:pPr>
-            <a:r>
-              <a:rPr lang="en-US" sz="1300" i="1" dirty="0">
-                <a:solidFill>
-                  <a:srgbClr val="5B6B7B"/>
-                </a:solidFill>
-                <a:latin typeface="Calibri" pitchFamily="34" charset="0"/>
-                <a:ea typeface="Calibri" pitchFamily="34" charset="-122"/>
-                <a:cs typeface="Calibri" pitchFamily="34" charset="-120"/>
-              </a:rPr>
-              <a:t>No chat sidebar. The dispatcher's unit of work is a decision, not a conversation.</a:t>
-            </a:r>
-            <a:endParaRPr lang="en-US" sz="1300" dirty="0"/>
           </a:p>
         </p:txBody>
       </p:sp>
@@ -3295,6 +3006,7 @@
         <a:solidFill>
           <a:srgbClr val="FFFFFF"/>
         </a:solidFill>
+        <a:effectLst/>
       </p:bgPr>
     </p:bg>
     <p:spTree>
@@ -3332,11 +3044,11 @@
           <a:bodyPr wrap="square" lIns="0" tIns="0" rIns="0" bIns="0" rtlCol="0" anchor="ctr"/>
           <a:lstStyle/>
           <a:p>
-            <a:pPr indent="0" marL="0">
-              <a:buNone/>
-            </a:pPr>
-            <a:r>
-              <a:rPr lang="en-US" sz="1200" b="1" spc="300" kern="0" dirty="0">
+            <a:pPr marL="0" indent="0">
+              <a:buNone/>
+            </a:pPr>
+            <a:r>
+              <a:rPr lang="en-US" sz="1200" b="1" kern="0" spc="300" dirty="0">
                 <a:solidFill>
                   <a:srgbClr val="2489E9"/>
                 </a:solidFill>
@@ -3371,7 +3083,7 @@
           <a:bodyPr wrap="square" lIns="0" tIns="0" rIns="0" bIns="0" rtlCol="0" anchor="ctr"/>
           <a:lstStyle/>
           <a:p>
-            <a:pPr indent="0" marL="0">
+            <a:pPr marL="0" indent="0">
               <a:buNone/>
             </a:pPr>
             <a:r>
@@ -3383,7 +3095,7 @@
                 <a:ea typeface="Arial" pitchFamily="34" charset="-122"/>
                 <a:cs typeface="Arial" pitchFamily="34" charset="-120"/>
               </a:rPr>
-              <a:t>Five surfaces. Five pain points. Nothing else.</a:t>
+              <a:t>Five surfaces. Five pain points.</a:t>
             </a:r>
             <a:endParaRPr lang="en-US" sz="3200" dirty="0"/>
           </a:p>
@@ -3437,7 +3149,7 @@
           <a:bodyPr wrap="square" lIns="0" tIns="0" rIns="0" bIns="0" rtlCol="0" anchor="ctr"/>
           <a:lstStyle/>
           <a:p>
-            <a:pPr indent="0" marL="0">
+            <a:pPr marL="0" indent="0">
               <a:buNone/>
             </a:pPr>
             <a:r>
@@ -3449,7 +3161,7 @@
                 <a:ea typeface="Arial" pitchFamily="34" charset="-122"/>
                 <a:cs typeface="Arial" pitchFamily="34" charset="-120"/>
               </a:rPr>
-              <a:t>Operations — Proactive Alerts</a:t>
+              <a:t>Operations - Proactive Alerts</a:t>
             </a:r>
             <a:endParaRPr lang="en-US" sz="1400" dirty="0"/>
           </a:p>
@@ -3476,7 +3188,7 @@
           <a:bodyPr wrap="square" lIns="0" tIns="0" rIns="0" bIns="0" rtlCol="0" anchor="t"/>
           <a:lstStyle/>
           <a:p>
-            <a:pPr indent="0" marL="0">
+            <a:pPr marL="0" indent="0">
               <a:lnSpc>
                 <a:spcPct val="112000"/>
               </a:lnSpc>
@@ -3545,7 +3257,7 @@
           <a:bodyPr wrap="square" lIns="0" tIns="0" rIns="0" bIns="0" rtlCol="0" anchor="ctr"/>
           <a:lstStyle/>
           <a:p>
-            <a:pPr indent="0" marL="0">
+            <a:pPr marL="0" indent="0">
               <a:buNone/>
             </a:pPr>
             <a:r>
@@ -3557,7 +3269,7 @@
                 <a:ea typeface="Arial" pitchFamily="34" charset="-122"/>
                 <a:cs typeface="Arial" pitchFamily="34" charset="-120"/>
               </a:rPr>
-              <a:t>Dispatch — Smart Dispatch</a:t>
+              <a:t>Dispatch - Smart Dispatch</a:t>
             </a:r>
             <a:endParaRPr lang="en-US" sz="1400" dirty="0"/>
           </a:p>
@@ -3584,7 +3296,7 @@
           <a:bodyPr wrap="square" lIns="0" tIns="0" rIns="0" bIns="0" rtlCol="0" anchor="t"/>
           <a:lstStyle/>
           <a:p>
-            <a:pPr indent="0" marL="0">
+            <a:pPr marL="0" indent="0">
               <a:lnSpc>
                 <a:spcPct val="112000"/>
               </a:lnSpc>
@@ -3653,7 +3365,7 @@
           <a:bodyPr wrap="square" lIns="0" tIns="0" rIns="0" bIns="0" rtlCol="0" anchor="ctr"/>
           <a:lstStyle/>
           <a:p>
-            <a:pPr indent="0" marL="0">
+            <a:pPr marL="0" indent="0">
               <a:buNone/>
             </a:pPr>
             <a:r>
@@ -3665,7 +3377,7 @@
                 <a:ea typeface="Arial" pitchFamily="34" charset="-122"/>
                 <a:cs typeface="Arial" pitchFamily="34" charset="-120"/>
               </a:rPr>
-              <a:t>Cost — Cost Intelligence</a:t>
+              <a:t>Cost - Cost Intelligence</a:t>
             </a:r>
             <a:endParaRPr lang="en-US" sz="1400" dirty="0"/>
           </a:p>
@@ -3692,7 +3404,7 @@
           <a:bodyPr wrap="square" lIns="0" tIns="0" rIns="0" bIns="0" rtlCol="0" anchor="t"/>
           <a:lstStyle/>
           <a:p>
-            <a:pPr indent="0" marL="0">
+            <a:pPr marL="0" indent="0">
               <a:lnSpc>
                 <a:spcPct val="112000"/>
               </a:lnSpc>
@@ -3761,7 +3473,7 @@
           <a:bodyPr wrap="square" lIns="0" tIns="0" rIns="0" bIns="0" rtlCol="0" anchor="ctr"/>
           <a:lstStyle/>
           <a:p>
-            <a:pPr indent="0" marL="0">
+            <a:pPr marL="0" indent="0">
               <a:buNone/>
             </a:pPr>
             <a:r>
@@ -3773,7 +3485,7 @@
                 <a:ea typeface="Arial" pitchFamily="34" charset="-122"/>
                 <a:cs typeface="Arial" pitchFamily="34" charset="-120"/>
               </a:rPr>
-              <a:t>Safety — Compliance</a:t>
+              <a:t>Safety - Compliance</a:t>
             </a:r>
             <a:endParaRPr lang="en-US" sz="1400" dirty="0"/>
           </a:p>
@@ -3800,7 +3512,7 @@
           <a:bodyPr wrap="square" lIns="0" tIns="0" rIns="0" bIns="0" rtlCol="0" anchor="t"/>
           <a:lstStyle/>
           <a:p>
-            <a:pPr indent="0" marL="0">
+            <a:pPr marL="0" indent="0">
               <a:lnSpc>
                 <a:spcPct val="112000"/>
               </a:lnSpc>
@@ -3869,7 +3581,7 @@
           <a:bodyPr wrap="square" lIns="0" tIns="0" rIns="0" bIns="0" rtlCol="0" anchor="ctr"/>
           <a:lstStyle/>
           <a:p>
-            <a:pPr indent="0" marL="0">
+            <a:pPr marL="0" indent="0">
               <a:buNone/>
             </a:pPr>
             <a:r>
@@ -3881,7 +3593,7 @@
                 <a:ea typeface="Arial" pitchFamily="34" charset="-122"/>
                 <a:cs typeface="Arial" pitchFamily="34" charset="-120"/>
               </a:rPr>
-              <a:t>Billing — Document Automation</a:t>
+              <a:t>Billing - Document Automation</a:t>
             </a:r>
             <a:endParaRPr lang="en-US" sz="1400" dirty="0"/>
           </a:p>
@@ -3908,7 +3620,7 @@
           <a:bodyPr wrap="square" lIns="0" tIns="0" rIns="0" bIns="0" rtlCol="0" anchor="t"/>
           <a:lstStyle/>
           <a:p>
-            <a:pPr indent="0" marL="0">
+            <a:pPr marL="0" indent="0">
               <a:lnSpc>
                 <a:spcPct val="112000"/>
               </a:lnSpc>
@@ -3977,7 +3689,7 @@
           <a:bodyPr wrap="square" lIns="0" tIns="0" rIns="0" bIns="0" rtlCol="0" anchor="ctr"/>
           <a:lstStyle/>
           <a:p>
-            <a:pPr indent="0" marL="0">
+            <a:pPr marL="0" indent="0">
               <a:buNone/>
             </a:pPr>
             <a:r>
@@ -3989,7 +3701,7 @@
                 <a:ea typeface="Arial" pitchFamily="34" charset="-122"/>
                 <a:cs typeface="Arial" pitchFamily="34" charset="-120"/>
               </a:rPr>
-              <a:t>Everywhere — Trust primitives</a:t>
+              <a:t>Everywhere - Trust primitives</a:t>
             </a:r>
             <a:endParaRPr lang="en-US" sz="1400" dirty="0"/>
           </a:p>
@@ -4016,7 +3728,7 @@
           <a:bodyPr wrap="square" lIns="0" tIns="0" rIns="0" bIns="0" rtlCol="0" anchor="t"/>
           <a:lstStyle/>
           <a:p>
-            <a:pPr indent="0" marL="0">
+            <a:pPr marL="0" indent="0">
               <a:lnSpc>
                 <a:spcPct val="112000"/>
               </a:lnSpc>
@@ -4053,6 +3765,7 @@
         <a:solidFill>
           <a:srgbClr val="FFFFFF"/>
         </a:solidFill>
+        <a:effectLst/>
       </p:bgPr>
     </p:bg>
     <p:spTree>
@@ -4090,11 +3803,11 @@
           <a:bodyPr wrap="square" lIns="0" tIns="0" rIns="0" bIns="0" rtlCol="0" anchor="ctr"/>
           <a:lstStyle/>
           <a:p>
-            <a:pPr indent="0" marL="0">
-              <a:buNone/>
-            </a:pPr>
-            <a:r>
-              <a:rPr lang="en-US" sz="1200" b="1" spc="300" kern="0" dirty="0">
+            <a:pPr marL="0" indent="0">
+              <a:buNone/>
+            </a:pPr>
+            <a:r>
+              <a:rPr lang="en-US" sz="1200" b="1" kern="0" spc="300" dirty="0">
                 <a:solidFill>
                   <a:srgbClr val="2489E9"/>
                 </a:solidFill>
@@ -4129,7 +3842,7 @@
           <a:bodyPr wrap="square" lIns="0" tIns="0" rIns="0" bIns="0" rtlCol="0" anchor="ctr"/>
           <a:lstStyle/>
           <a:p>
-            <a:pPr indent="0" marL="0">
+            <a:pPr marL="0" indent="0">
               <a:buNone/>
             </a:pPr>
             <a:r>
@@ -4141,7 +3854,7 @@
                 <a:ea typeface="Arial" pitchFamily="34" charset="-122"/>
                 <a:cs typeface="Arial" pitchFamily="34" charset="-120"/>
               </a:rPr>
-              <a:t>The model reasons. The code computes. The human decides.</a:t>
+              <a:t>The model reasons. The code computes. The dispatcher decides.</a:t>
             </a:r>
             <a:endParaRPr lang="en-US" sz="3200" dirty="0"/>
           </a:p>
@@ -4195,7 +3908,7 @@
           <a:bodyPr wrap="square" lIns="0" tIns="0" rIns="0" bIns="0" rtlCol="0" anchor="ctr"/>
           <a:lstStyle/>
           <a:p>
-            <a:pPr indent="0" marL="0">
+            <a:pPr marL="0" indent="0">
               <a:buNone/>
             </a:pPr>
             <a:r>
@@ -4234,7 +3947,7 @@
           <a:bodyPr wrap="square" lIns="0" tIns="0" rIns="0" bIns="0" rtlCol="0" anchor="t"/>
           <a:lstStyle/>
           <a:p>
-            <a:pPr indent="0" marL="0">
+            <a:pPr marL="0" indent="0">
               <a:lnSpc>
                 <a:spcPct val="112000"/>
               </a:lnSpc>
@@ -4303,7 +4016,7 @@
           <a:bodyPr wrap="square" lIns="0" tIns="0" rIns="0" bIns="0" rtlCol="0" anchor="ctr"/>
           <a:lstStyle/>
           <a:p>
-            <a:pPr indent="0" marL="0">
+            <a:pPr marL="0" indent="0">
               <a:buNone/>
             </a:pPr>
             <a:r>
@@ -4342,7 +4055,7 @@
           <a:bodyPr wrap="square" lIns="0" tIns="0" rIns="0" bIns="0" rtlCol="0" anchor="t"/>
           <a:lstStyle/>
           <a:p>
-            <a:pPr indent="0" marL="0">
+            <a:pPr marL="0" indent="0">
               <a:lnSpc>
                 <a:spcPct val="112000"/>
               </a:lnSpc>
@@ -4357,7 +4070,7 @@
                 <a:ea typeface="Calibri" pitchFamily="34" charset="-122"/>
                 <a:cs typeface="Calibri" pitchFamily="34" charset="-120"/>
               </a:rPr>
-              <a:t>NL→SQL runs on a read-only SQLite connection with an authorizer: SELECT-only, denylisted tables, row caps, VM-step budget. Money math is never delegated to the model — the reconciler and HOS ledger are code.</a:t>
+              <a:t>NL→SQL runs on a read-only SQLite connection with an authorizer: SELECT-only, denylisted tables, row caps, VM-step budget. Money math is never delegated to the model - the reconciler and HOS ledger are code.</a:t>
             </a:r>
             <a:endParaRPr lang="en-US" sz="1150" dirty="0"/>
           </a:p>
@@ -4411,7 +4124,7 @@
           <a:bodyPr wrap="square" lIns="0" tIns="0" rIns="0" bIns="0" rtlCol="0" anchor="ctr"/>
           <a:lstStyle/>
           <a:p>
-            <a:pPr indent="0" marL="0">
+            <a:pPr marL="0" indent="0">
               <a:buNone/>
             </a:pPr>
             <a:r>
@@ -4450,7 +4163,7 @@
           <a:bodyPr wrap="square" lIns="0" tIns="0" rIns="0" bIns="0" rtlCol="0" anchor="t"/>
           <a:lstStyle/>
           <a:p>
-            <a:pPr indent="0" marL="0">
+            <a:pPr marL="0" indent="0">
               <a:lnSpc>
                 <a:spcPct val="112000"/>
               </a:lnSpc>
@@ -4519,7 +4232,7 @@
           <a:bodyPr wrap="square" lIns="0" tIns="0" rIns="0" bIns="0" rtlCol="0" anchor="ctr"/>
           <a:lstStyle/>
           <a:p>
-            <a:pPr indent="0" marL="0">
+            <a:pPr marL="0" indent="0">
               <a:lnSpc>
                 <a:spcPct val="130000"/>
               </a:lnSpc>
@@ -4539,7 +4252,7 @@
             <a:endParaRPr lang="en-US" sz="1100" dirty="0"/>
           </a:p>
           <a:p>
-            <a:pPr indent="0" marL="0">
+            <a:pPr marL="0" indent="0">
               <a:lnSpc>
                 <a:spcPct val="130000"/>
               </a:lnSpc>
@@ -4576,6 +4289,7 @@
         <a:solidFill>
           <a:srgbClr val="FFFFFF"/>
         </a:solidFill>
+        <a:effectLst/>
       </p:bgPr>
     </p:bg>
     <p:spTree>
@@ -4613,11 +4327,11 @@
           <a:bodyPr wrap="square" lIns="0" tIns="0" rIns="0" bIns="0" rtlCol="0" anchor="ctr"/>
           <a:lstStyle/>
           <a:p>
-            <a:pPr indent="0" marL="0">
-              <a:buNone/>
-            </a:pPr>
-            <a:r>
-              <a:rPr lang="en-US" sz="1200" b="1" spc="300" kern="0" dirty="0">
+            <a:pPr marL="0" indent="0">
+              <a:buNone/>
+            </a:pPr>
+            <a:r>
+              <a:rPr lang="en-US" sz="1200" b="1" kern="0" spc="300" dirty="0">
                 <a:solidFill>
                   <a:srgbClr val="2489E9"/>
                 </a:solidFill>
@@ -4652,7 +4366,7 @@
           <a:bodyPr wrap="square" lIns="0" tIns="0" rIns="0" bIns="0" rtlCol="0" anchor="ctr"/>
           <a:lstStyle/>
           <a:p>
-            <a:pPr indent="0" marL="0">
+            <a:pPr marL="0" indent="0">
               <a:buNone/>
             </a:pPr>
             <a:r>
@@ -4718,7 +4432,7 @@
           <a:bodyPr wrap="square" lIns="0" tIns="0" rIns="0" bIns="0" rtlCol="0" anchor="ctr"/>
           <a:lstStyle/>
           <a:p>
-            <a:pPr indent="0" marL="0">
+            <a:pPr marL="0" indent="0">
               <a:buNone/>
             </a:pPr>
             <a:r>
@@ -4730,7 +4444,7 @@
                 <a:ea typeface="Arial" pitchFamily="34" charset="-122"/>
                 <a:cs typeface="Arial" pitchFamily="34" charset="-120"/>
               </a:rPr>
-              <a:t>Historical warehouse — real</a:t>
+              <a:t>Historical warehouse - real</a:t>
             </a:r>
             <a:endParaRPr lang="en-US" sz="1400" dirty="0"/>
           </a:p>
@@ -4757,7 +4471,7 @@
           <a:bodyPr wrap="square" lIns="0" tIns="0" rIns="0" bIns="0" rtlCol="0" anchor="t"/>
           <a:lstStyle/>
           <a:p>
-            <a:pPr indent="0" marL="0">
+            <a:pPr marL="0" indent="0">
               <a:lnSpc>
                 <a:spcPct val="112000"/>
               </a:lnSpc>
@@ -4826,7 +4540,7 @@
           <a:bodyPr wrap="square" lIns="0" tIns="0" rIns="0" bIns="0" rtlCol="0" anchor="ctr"/>
           <a:lstStyle/>
           <a:p>
-            <a:pPr indent="0" marL="0">
+            <a:pPr marL="0" indent="0">
               <a:buNone/>
             </a:pPr>
             <a:r>
@@ -4838,7 +4552,7 @@
                 <a:ea typeface="Arial" pitchFamily="34" charset="-122"/>
                 <a:cs typeface="Arial" pitchFamily="34" charset="-120"/>
               </a:rPr>
-              <a:t>Live plane — simulated forward</a:t>
+              <a:t>Live plane - simulated forward</a:t>
             </a:r>
             <a:endParaRPr lang="en-US" sz="1400" dirty="0"/>
           </a:p>
@@ -4865,7 +4579,7 @@
           <a:bodyPr wrap="square" lIns="0" tIns="0" rIns="0" bIns="0" rtlCol="0" anchor="t"/>
           <a:lstStyle/>
           <a:p>
-            <a:pPr indent="0" marL="0">
+            <a:pPr marL="0" indent="0">
               <a:lnSpc>
                 <a:spcPct val="112000"/>
               </a:lnSpc>
@@ -4934,7 +4648,7 @@
           <a:bodyPr wrap="square" lIns="0" tIns="0" rIns="0" bIns="0" rtlCol="0" anchor="ctr"/>
           <a:lstStyle/>
           <a:p>
-            <a:pPr indent="0" marL="0">
+            <a:pPr marL="0" indent="0">
               <a:buNone/>
             </a:pPr>
             <a:r>
@@ -4973,7 +4687,7 @@
           <a:bodyPr wrap="square" lIns="0" tIns="0" rIns="0" bIns="0" rtlCol="0" anchor="t"/>
           <a:lstStyle/>
           <a:p>
-            <a:pPr indent="0" marL="0">
+            <a:pPr marL="0" indent="0">
               <a:lnSpc>
                 <a:spcPct val="112000"/>
               </a:lnSpc>
@@ -5042,7 +4756,7 @@
           <a:bodyPr wrap="square" lIns="0" tIns="0" rIns="0" bIns="0" rtlCol="0" anchor="ctr"/>
           <a:lstStyle/>
           <a:p>
-            <a:pPr indent="0" marL="0">
+            <a:pPr marL="0" indent="0">
               <a:buNone/>
             </a:pPr>
             <a:r>
@@ -5081,7 +4795,7 @@
           <a:bodyPr wrap="square" lIns="0" tIns="0" rIns="0" bIns="0" rtlCol="0" anchor="t"/>
           <a:lstStyle/>
           <a:p>
-            <a:pPr indent="0" marL="0">
+            <a:pPr marL="0" indent="0">
               <a:lnSpc>
                 <a:spcPct val="112000"/>
               </a:lnSpc>
@@ -5118,6 +4832,7 @@
         <a:solidFill>
           <a:srgbClr val="FFFFFF"/>
         </a:solidFill>
+        <a:effectLst/>
       </p:bgPr>
     </p:bg>
     <p:spTree>
@@ -5155,11 +4870,11 @@
           <a:bodyPr wrap="square" lIns="0" tIns="0" rIns="0" bIns="0" rtlCol="0" anchor="ctr"/>
           <a:lstStyle/>
           <a:p>
-            <a:pPr indent="0" marL="0">
-              <a:buNone/>
-            </a:pPr>
-            <a:r>
-              <a:rPr lang="en-US" sz="1200" b="1" spc="300" kern="0" dirty="0">
+            <a:pPr marL="0" indent="0">
+              <a:buNone/>
+            </a:pPr>
+            <a:r>
+              <a:rPr lang="en-US" sz="1200" b="1" kern="0" spc="300" dirty="0">
                 <a:solidFill>
                   <a:srgbClr val="2489E9"/>
                 </a:solidFill>
@@ -5194,7 +4909,7 @@
           <a:bodyPr wrap="square" lIns="0" tIns="0" rIns="0" bIns="0" rtlCol="0" anchor="ctr"/>
           <a:lstStyle/>
           <a:p>
-            <a:pPr indent="0" marL="0">
+            <a:pPr marL="0" indent="0">
               <a:buNone/>
             </a:pPr>
             <a:r>
@@ -5206,7 +4921,7 @@
                 <a:ea typeface="Arial" pitchFamily="34" charset="-122"/>
                 <a:cs typeface="Arial" pitchFamily="34" charset="-120"/>
               </a:rPr>
-              <a:t>Cut scope, kept honesty.</a:t>
+              <a:t>Cut scope.</a:t>
             </a:r>
             <a:endParaRPr lang="en-US" sz="3200" dirty="0"/>
           </a:p>
@@ -5260,7 +4975,7 @@
           <a:bodyPr wrap="square" lIns="0" tIns="0" rIns="0" bIns="0" rtlCol="0" anchor="ctr"/>
           <a:lstStyle/>
           <a:p>
-            <a:pPr indent="0" marL="0">
+            <a:pPr marL="0" indent="0">
               <a:buNone/>
             </a:pPr>
             <a:r>
@@ -5299,7 +5014,7 @@
           <a:bodyPr wrap="square" lIns="0" tIns="0" rIns="0" bIns="0" rtlCol="0" anchor="t"/>
           <a:lstStyle/>
           <a:p>
-            <a:pPr indent="0" marL="0">
+            <a:pPr marL="0" indent="0">
               <a:lnSpc>
                 <a:spcPct val="112000"/>
               </a:lnSpc>
@@ -5368,7 +5083,7 @@
           <a:bodyPr wrap="square" lIns="0" tIns="0" rIns="0" bIns="0" rtlCol="0" anchor="ctr"/>
           <a:lstStyle/>
           <a:p>
-            <a:pPr indent="0" marL="0">
+            <a:pPr marL="0" indent="0">
               <a:buNone/>
             </a:pPr>
             <a:r>
@@ -5407,7 +5122,7 @@
           <a:bodyPr wrap="square" lIns="0" tIns="0" rIns="0" bIns="0" rtlCol="0" anchor="t"/>
           <a:lstStyle/>
           <a:p>
-            <a:pPr indent="0" marL="0">
+            <a:pPr marL="0" indent="0">
               <a:lnSpc>
                 <a:spcPct val="112000"/>
               </a:lnSpc>
@@ -5476,7 +5191,7 @@
           <a:bodyPr wrap="square" lIns="0" tIns="0" rIns="0" bIns="0" rtlCol="0" anchor="ctr"/>
           <a:lstStyle/>
           <a:p>
-            <a:pPr indent="0" marL="0">
+            <a:pPr marL="0" indent="0">
               <a:buNone/>
             </a:pPr>
             <a:r>
@@ -5515,7 +5230,7 @@
           <a:bodyPr wrap="square" lIns="0" tIns="0" rIns="0" bIns="0" rtlCol="0" anchor="t"/>
           <a:lstStyle/>
           <a:p>
-            <a:pPr indent="0" marL="0">
+            <a:pPr marL="0" indent="0">
               <a:lnSpc>
                 <a:spcPct val="112000"/>
               </a:lnSpc>
@@ -5584,7 +5299,7 @@
           <a:bodyPr wrap="square" lIns="0" tIns="0" rIns="0" bIns="0" rtlCol="0" anchor="ctr"/>
           <a:lstStyle/>
           <a:p>
-            <a:pPr indent="0" marL="0">
+            <a:pPr marL="0" indent="0">
               <a:buNone/>
             </a:pPr>
             <a:r>
@@ -5623,7 +5338,7 @@
           <a:bodyPr wrap="square" lIns="0" tIns="0" rIns="0" bIns="0" rtlCol="0" anchor="t"/>
           <a:lstStyle/>
           <a:p>
-            <a:pPr indent="0" marL="0">
+            <a:pPr marL="0" indent="0">
               <a:lnSpc>
                 <a:spcPct val="112000"/>
               </a:lnSpc>
@@ -5660,6 +5375,7 @@
         <a:solidFill>
           <a:srgbClr val="FFFFFF"/>
         </a:solidFill>
+        <a:effectLst/>
       </p:bgPr>
     </p:bg>
     <p:spTree>
@@ -5697,11 +5413,11 @@
           <a:bodyPr wrap="square" lIns="0" tIns="0" rIns="0" bIns="0" rtlCol="0" anchor="ctr"/>
           <a:lstStyle/>
           <a:p>
-            <a:pPr indent="0" marL="0">
-              <a:buNone/>
-            </a:pPr>
-            <a:r>
-              <a:rPr lang="en-US" sz="1200" b="1" spc="300" kern="0" dirty="0">
+            <a:pPr marL="0" indent="0">
+              <a:buNone/>
+            </a:pPr>
+            <a:r>
+              <a:rPr lang="en-US" sz="1200" b="1" kern="0" spc="300" dirty="0">
                 <a:solidFill>
                   <a:srgbClr val="2489E9"/>
                 </a:solidFill>
@@ -5736,7 +5452,7 @@
           <a:bodyPr wrap="square" lIns="0" tIns="0" rIns="0" bIns="0" rtlCol="0" anchor="ctr"/>
           <a:lstStyle/>
           <a:p>
-            <a:pPr indent="0" marL="0">
+            <a:pPr marL="0" indent="0">
               <a:buNone/>
             </a:pPr>
             <a:r>
@@ -5802,7 +5518,7 @@
           <a:bodyPr wrap="square" lIns="0" tIns="0" rIns="0" bIns="0" rtlCol="0" anchor="ctr"/>
           <a:lstStyle/>
           <a:p>
-            <a:pPr indent="0" marL="0">
+            <a:pPr marL="0" indent="0">
               <a:buNone/>
             </a:pPr>
             <a:r>
@@ -5841,7 +5557,7 @@
           <a:bodyPr wrap="square" lIns="0" tIns="0" rIns="0" bIns="0" rtlCol="0" anchor="ctr"/>
           <a:lstStyle/>
           <a:p>
-            <a:pPr indent="0" marL="0">
+            <a:pPr marL="0" indent="0">
               <a:buNone/>
             </a:pPr>
             <a:r>
@@ -5907,7 +5623,7 @@
           <a:bodyPr wrap="square" lIns="0" tIns="0" rIns="0" bIns="0" rtlCol="0" anchor="ctr"/>
           <a:lstStyle/>
           <a:p>
-            <a:pPr indent="0" marL="0">
+            <a:pPr marL="0" indent="0">
               <a:buNone/>
             </a:pPr>
             <a:r>
@@ -5946,7 +5662,7 @@
           <a:bodyPr wrap="square" lIns="0" tIns="0" rIns="0" bIns="0" rtlCol="0" anchor="t"/>
           <a:lstStyle/>
           <a:p>
-            <a:pPr indent="0" marL="0">
+            <a:pPr marL="0" indent="0">
               <a:lnSpc>
                 <a:spcPct val="112000"/>
               </a:lnSpc>
@@ -6015,7 +5731,7 @@
           <a:bodyPr wrap="square" lIns="0" tIns="0" rIns="0" bIns="0" rtlCol="0" anchor="ctr"/>
           <a:lstStyle/>
           <a:p>
-            <a:pPr indent="0" marL="0">
+            <a:pPr marL="0" indent="0">
               <a:buNone/>
             </a:pPr>
             <a:r>
@@ -6054,7 +5770,7 @@
           <a:bodyPr wrap="square" lIns="0" tIns="0" rIns="0" bIns="0" rtlCol="0" anchor="t"/>
           <a:lstStyle/>
           <a:p>
-            <a:pPr indent="0" marL="0">
+            <a:pPr marL="0" indent="0">
               <a:lnSpc>
                 <a:spcPct val="112000"/>
               </a:lnSpc>
@@ -6123,7 +5839,7 @@
           <a:bodyPr wrap="square" lIns="0" tIns="0" rIns="0" bIns="0" rtlCol="0" anchor="ctr"/>
           <a:lstStyle/>
           <a:p>
-            <a:pPr indent="0" marL="0">
+            <a:pPr marL="0" indent="0">
               <a:buNone/>
             </a:pPr>
             <a:r>
@@ -6162,7 +5878,7 @@
           <a:bodyPr wrap="square" lIns="0" tIns="0" rIns="0" bIns="0" rtlCol="0" anchor="t"/>
           <a:lstStyle/>
           <a:p>
-            <a:pPr indent="0" marL="0">
+            <a:pPr marL="0" indent="0">
               <a:lnSpc>
                 <a:spcPct val="112000"/>
               </a:lnSpc>
@@ -6231,7 +5947,7 @@
           <a:bodyPr wrap="square" lIns="0" tIns="0" rIns="0" bIns="0" rtlCol="0" anchor="ctr"/>
           <a:lstStyle/>
           <a:p>
-            <a:pPr indent="0" marL="0">
+            <a:pPr marL="0" indent="0">
               <a:buNone/>
             </a:pPr>
             <a:r>
@@ -6270,7 +5986,7 @@
           <a:bodyPr wrap="square" lIns="0" tIns="0" rIns="0" bIns="0" rtlCol="0" anchor="t"/>
           <a:lstStyle/>
           <a:p>
-            <a:pPr indent="0" marL="0">
+            <a:pPr marL="0" indent="0">
               <a:lnSpc>
                 <a:spcPct val="112000"/>
               </a:lnSpc>
@@ -6339,7 +6055,7 @@
           <a:bodyPr wrap="square" lIns="0" tIns="0" rIns="0" bIns="0" rtlCol="0" anchor="ctr"/>
           <a:lstStyle/>
           <a:p>
-            <a:pPr indent="0" marL="0">
+            <a:pPr marL="0" indent="0">
               <a:buNone/>
             </a:pPr>
             <a:r>
@@ -6378,7 +6094,7 @@
           <a:bodyPr wrap="square" lIns="0" tIns="0" rIns="0" bIns="0" rtlCol="0" anchor="t"/>
           <a:lstStyle/>
           <a:p>
-            <a:pPr indent="0" marL="0">
+            <a:pPr marL="0" indent="0">
               <a:lnSpc>
                 <a:spcPct val="112000"/>
               </a:lnSpc>
@@ -6415,6 +6131,7 @@
         <a:solidFill>
           <a:srgbClr val="FFFFFF"/>
         </a:solidFill>
+        <a:effectLst/>
       </p:bgPr>
     </p:bg>
     <p:spTree>
@@ -6452,11 +6169,11 @@
           <a:bodyPr wrap="square" lIns="0" tIns="0" rIns="0" bIns="0" rtlCol="0" anchor="ctr"/>
           <a:lstStyle/>
           <a:p>
-            <a:pPr indent="0" marL="0">
-              <a:buNone/>
-            </a:pPr>
-            <a:r>
-              <a:rPr lang="en-US" sz="1200" b="1" spc="300" kern="0" dirty="0">
+            <a:pPr marL="0" indent="0">
+              <a:buNone/>
+            </a:pPr>
+            <a:r>
+              <a:rPr lang="en-US" sz="1200" b="1" kern="0" spc="300" dirty="0">
                 <a:solidFill>
                   <a:srgbClr val="2489E9"/>
                 </a:solidFill>
@@ -6491,7 +6208,7 @@
           <a:bodyPr wrap="square" lIns="0" tIns="0" rIns="0" bIns="0" rtlCol="0" anchor="ctr"/>
           <a:lstStyle/>
           <a:p>
-            <a:pPr indent="0" marL="0">
+            <a:pPr marL="0" indent="0">
               <a:buNone/>
             </a:pPr>
             <a:r>
@@ -6557,7 +6274,7 @@
           <a:bodyPr wrap="square" lIns="0" tIns="0" rIns="0" bIns="0" rtlCol="0" anchor="ctr"/>
           <a:lstStyle/>
           <a:p>
-            <a:pPr indent="0" marL="0">
+            <a:pPr marL="0" indent="0">
               <a:buNone/>
             </a:pPr>
             <a:r>
@@ -6596,7 +6313,7 @@
           <a:bodyPr wrap="square" lIns="0" tIns="0" rIns="0" bIns="0" rtlCol="0" anchor="t"/>
           <a:lstStyle/>
           <a:p>
-            <a:pPr indent="0" marL="0">
+            <a:pPr marL="0" indent="0">
               <a:lnSpc>
                 <a:spcPct val="112000"/>
               </a:lnSpc>
@@ -6611,7 +6328,7 @@
                 <a:ea typeface="Calibri" pitchFamily="34" charset="-122"/>
                 <a:cs typeface="Calibri" pitchFamily="34" charset="-120"/>
               </a:rPr>
-              <a:t>5–50 truck for-hire fleets — ~50k US carriers. One dispatcher wearing four hats; no TMS, or a TMS they hate. Willingness to pay tracks saved hours and recovered detention, both measurable in-product.</a:t>
+              <a:t>5-50 truck for hire fleets - ~50k US carriers. One dispatcher wearing four hats; no TMS, or a TMS they hate. Willingness to pay tracks saved hours and recovered detention, both measurable in-product.</a:t>
             </a:r>
             <a:endParaRPr lang="en-US" sz="1150" dirty="0"/>
           </a:p>
@@ -6665,7 +6382,7 @@
           <a:bodyPr wrap="square" lIns="0" tIns="0" rIns="0" bIns="0" rtlCol="0" anchor="ctr"/>
           <a:lstStyle/>
           <a:p>
-            <a:pPr indent="0" marL="0">
+            <a:pPr marL="0" indent="0">
               <a:buNone/>
             </a:pPr>
             <a:r>
@@ -6704,7 +6421,7 @@
           <a:bodyPr wrap="square" lIns="0" tIns="0" rIns="0" bIns="0" rtlCol="0" anchor="t"/>
           <a:lstStyle/>
           <a:p>
-            <a:pPr indent="0" marL="0">
+            <a:pPr marL="0" indent="0">
               <a:lnSpc>
                 <a:spcPct val="112000"/>
               </a:lnSpc>
@@ -6773,7 +6490,7 @@
           <a:bodyPr wrap="square" lIns="0" tIns="0" rIns="0" bIns="0" rtlCol="0" anchor="ctr"/>
           <a:lstStyle/>
           <a:p>
-            <a:pPr indent="0" marL="0">
+            <a:pPr marL="0" indent="0">
               <a:buNone/>
             </a:pPr>
             <a:r>
@@ -6812,7 +6529,7 @@
           <a:bodyPr wrap="square" lIns="0" tIns="0" rIns="0" bIns="0" rtlCol="0" anchor="t"/>
           <a:lstStyle/>
           <a:p>
-            <a:pPr indent="0" marL="0">
+            <a:pPr marL="0" indent="0">
               <a:lnSpc>
                 <a:spcPct val="112000"/>
               </a:lnSpc>
@@ -6854,7 +6571,7 @@
           <a:bodyPr wrap="square" lIns="0" tIns="0" rIns="0" bIns="0" rtlCol="0" anchor="ctr"/>
           <a:lstStyle/>
           <a:p>
-            <a:pPr indent="0" marL="0">
+            <a:pPr marL="0" indent="0">
               <a:buNone/>
             </a:pPr>
             <a:r>
@@ -7173,4 +6890,299 @@
     </a:ext>
   </a:extLst>
 </a:theme>
+</file>
+
+<file path=ppt/theme/theme2.xml><?xml version="1.0" encoding="utf-8"?>
+<a:theme xmlns:a="http://schemas.openxmlformats.org/drawingml/2006/main" name="Office Theme">
+  <a:themeElements>
+    <a:clrScheme name="Office">
+      <a:dk1>
+        <a:sysClr val="windowText" lastClr="000000"/>
+      </a:dk1>
+      <a:lt1>
+        <a:sysClr val="window" lastClr="FFFFFF"/>
+      </a:lt1>
+      <a:dk2>
+        <a:srgbClr val="44546A"/>
+      </a:dk2>
+      <a:lt2>
+        <a:srgbClr val="E7E6E6"/>
+      </a:lt2>
+      <a:accent1>
+        <a:srgbClr val="4472C4"/>
+      </a:accent1>
+      <a:accent2>
+        <a:srgbClr val="ED7D31"/>
+      </a:accent2>
+      <a:accent3>
+        <a:srgbClr val="A5A5A5"/>
+      </a:accent3>
+      <a:accent4>
+        <a:srgbClr val="FFC000"/>
+      </a:accent4>
+      <a:accent5>
+        <a:srgbClr val="5B9BD5"/>
+      </a:accent5>
+      <a:accent6>
+        <a:srgbClr val="70AD47"/>
+      </a:accent6>
+      <a:hlink>
+        <a:srgbClr val="0563C1"/>
+      </a:hlink>
+      <a:folHlink>
+        <a:srgbClr val="954F72"/>
+      </a:folHlink>
+    </a:clrScheme>
+    <a:fontScheme name="Office">
+      <a:majorFont>
+        <a:latin typeface="Calibri Light" panose="020F0302020204030204"/>
+        <a:ea typeface=""/>
+        <a:cs typeface=""/>
+        <a:font script="Jpan" typeface="游ゴシック Light"/>
+        <a:font script="Hang" typeface="맑은 고딕"/>
+        <a:font script="Hans" typeface="等线 Light"/>
+        <a:font script="Hant" typeface="新細明體"/>
+        <a:font script="Arab" typeface="Times New Roman"/>
+        <a:font script="Hebr" typeface="Times New Roman"/>
+        <a:font script="Thai" typeface="Angsana New"/>
+        <a:font script="Ethi" typeface="Nyala"/>
+        <a:font script="Beng" typeface="Vrinda"/>
+        <a:font script="Gujr" typeface="Shruti"/>
+        <a:font script="Khmr" typeface="MoolBoran"/>
+        <a:font script="Knda" typeface="Tunga"/>
+        <a:font script="Guru" typeface="Raavi"/>
+        <a:font script="Cans" typeface="Euphemia"/>
+        <a:font script="Cher" typeface="Plantagenet Cherokee"/>
+        <a:font script="Yiii" typeface="Microsoft Yi Baiti"/>
+        <a:font script="Tibt" typeface="Microsoft Himalaya"/>
+        <a:font script="Thaa" typeface="MV Boli"/>
+        <a:font script="Deva" typeface="Mangal"/>
+        <a:font script="Telu" typeface="Gautami"/>
+        <a:font script="Taml" typeface="Latha"/>
+        <a:font script="Syrc" typeface="Estrangelo Edessa"/>
+        <a:font script="Orya" typeface="Kalinga"/>
+        <a:font script="Mlym" typeface="Kartika"/>
+        <a:font script="Laoo" typeface="DokChampa"/>
+        <a:font script="Sinh" typeface="Iskoola Pota"/>
+        <a:font script="Mong" typeface="Mongolian Baiti"/>
+        <a:font script="Viet" typeface="Times New Roman"/>
+        <a:font script="Uigh" typeface="Microsoft Uighur"/>
+        <a:font script="Geor" typeface="Sylfaen"/>
+        <a:font script="Armn" typeface="Arial"/>
+        <a:font script="Bugi" typeface="Leelawadee UI"/>
+        <a:font script="Bopo" typeface="Microsoft JhengHei"/>
+        <a:font script="Java" typeface="Javanese Text"/>
+        <a:font script="Lisu" typeface="Segoe UI"/>
+        <a:font script="Mymr" typeface="Myanmar Text"/>
+        <a:font script="Nkoo" typeface="Ebrima"/>
+        <a:font script="Olck" typeface="Nirmala UI"/>
+        <a:font script="Osma" typeface="Ebrima"/>
+        <a:font script="Phag" typeface="Phagspa"/>
+        <a:font script="Syrn" typeface="Estrangelo Edessa"/>
+        <a:font script="Syrj" typeface="Estrangelo Edessa"/>
+        <a:font script="Syre" typeface="Estrangelo Edessa"/>
+        <a:font script="Sora" typeface="Nirmala UI"/>
+        <a:font script="Tale" typeface="Microsoft Tai Le"/>
+        <a:font script="Talu" typeface="Microsoft New Tai Lue"/>
+        <a:font script="Tfng" typeface="Ebrima"/>
+      </a:majorFont>
+      <a:minorFont>
+        <a:latin typeface="Calibri" panose="020F0502020204030204"/>
+        <a:ea typeface=""/>
+        <a:cs typeface=""/>
+        <a:font script="Jpan" typeface="游ゴシック"/>
+        <a:font script="Hang" typeface="맑은 고딕"/>
+        <a:font script="Hans" typeface="等线"/>
+        <a:font script="Hant" typeface="新細明體"/>
+        <a:font script="Arab" typeface="Arial"/>
+        <a:font script="Hebr" typeface="Arial"/>
+        <a:font script="Thai" typeface="Cordia New"/>
+        <a:font script="Ethi" typeface="Nyala"/>
+        <a:font script="Beng" typeface="Vrinda"/>
+        <a:font script="Gujr" typeface="Shruti"/>
+        <a:font script="Khmr" typeface="DaunPenh"/>
+        <a:font script="Knda" typeface="Tunga"/>
+        <a:font script="Guru" typeface="Raavi"/>
+        <a:font script="Cans" typeface="Euphemia"/>
+        <a:font script="Cher" typeface="Plantagenet Cherokee"/>
+        <a:font script="Yiii" typeface="Microsoft Yi Baiti"/>
+        <a:font script="Tibt" typeface="Microsoft Himalaya"/>
+        <a:font script="Thaa" typeface="MV Boli"/>
+        <a:font script="Deva" typeface="Mangal"/>
+        <a:font script="Telu" typeface="Gautami"/>
+        <a:font script="Taml" typeface="Latha"/>
+        <a:font script="Syrc" typeface="Estrangelo Edessa"/>
+        <a:font script="Orya" typeface="Kalinga"/>
+        <a:font script="Mlym" typeface="Kartika"/>
+        <a:font script="Laoo" typeface="DokChampa"/>
+        <a:font script="Sinh" typeface="Iskoola Pota"/>
+        <a:font script="Mong" typeface="Mongolian Baiti"/>
+        <a:font script="Viet" typeface="Arial"/>
+        <a:font script="Uigh" typeface="Microsoft Uighur"/>
+        <a:font script="Geor" typeface="Sylfaen"/>
+        <a:font script="Armn" typeface="Arial"/>
+        <a:font script="Bugi" typeface="Leelawadee UI"/>
+        <a:font script="Bopo" typeface="Microsoft JhengHei"/>
+        <a:font script="Java" typeface="Javanese Text"/>
+        <a:font script="Lisu" typeface="Segoe UI"/>
+        <a:font script="Mymr" typeface="Myanmar Text"/>
+        <a:font script="Nkoo" typeface="Ebrima"/>
+        <a:font script="Olck" typeface="Nirmala UI"/>
+        <a:font script="Osma" typeface="Ebrima"/>
+        <a:font script="Phag" typeface="Phagspa"/>
+        <a:font script="Syrn" typeface="Estrangelo Edessa"/>
+        <a:font script="Syrj" typeface="Estrangelo Edessa"/>
+        <a:font script="Syre" typeface="Estrangelo Edessa"/>
+        <a:font script="Sora" typeface="Nirmala UI"/>
+        <a:font script="Tale" typeface="Microsoft Tai Le"/>
+        <a:font script="Talu" typeface="Microsoft New Tai Lue"/>
+        <a:font script="Tfng" typeface="Ebrima"/>
+      </a:minorFont>
+    </a:fontScheme>
+    <a:fmtScheme name="Office">
+      <a:fillStyleLst>
+        <a:solidFill>
+          <a:schemeClr val="phClr"/>
+        </a:solidFill>
+        <a:gradFill rotWithShape="1">
+          <a:gsLst>
+            <a:gs pos="0">
+              <a:schemeClr val="phClr">
+                <a:lumMod val="110000"/>
+                <a:satMod val="105000"/>
+                <a:tint val="67000"/>
+              </a:schemeClr>
+            </a:gs>
+            <a:gs pos="50000">
+              <a:schemeClr val="phClr">
+                <a:lumMod val="105000"/>
+                <a:satMod val="103000"/>
+                <a:tint val="73000"/>
+              </a:schemeClr>
+            </a:gs>
+            <a:gs pos="100000">
+              <a:schemeClr val="phClr">
+                <a:lumMod val="105000"/>
+                <a:satMod val="109000"/>
+                <a:tint val="81000"/>
+              </a:schemeClr>
+            </a:gs>
+          </a:gsLst>
+          <a:lin ang="5400000" scaled="0"/>
+        </a:gradFill>
+        <a:gradFill rotWithShape="1">
+          <a:gsLst>
+            <a:gs pos="0">
+              <a:schemeClr val="phClr">
+                <a:satMod val="103000"/>
+                <a:lumMod val="102000"/>
+                <a:tint val="94000"/>
+              </a:schemeClr>
+            </a:gs>
+            <a:gs pos="50000">
+              <a:schemeClr val="phClr">
+                <a:satMod val="110000"/>
+                <a:lumMod val="100000"/>
+                <a:shade val="100000"/>
+              </a:schemeClr>
+            </a:gs>
+            <a:gs pos="100000">
+              <a:schemeClr val="phClr">
+                <a:lumMod val="99000"/>
+                <a:satMod val="120000"/>
+                <a:shade val="78000"/>
+              </a:schemeClr>
+            </a:gs>
+          </a:gsLst>
+          <a:lin ang="5400000" scaled="0"/>
+        </a:gradFill>
+      </a:fillStyleLst>
+      <a:lnStyleLst>
+        <a:ln w="6350" cap="flat" cmpd="sng" algn="ctr">
+          <a:solidFill>
+            <a:schemeClr val="phClr"/>
+          </a:solidFill>
+          <a:prstDash val="solid"/>
+          <a:miter lim="800000"/>
+        </a:ln>
+        <a:ln w="12700" cap="flat" cmpd="sng" algn="ctr">
+          <a:solidFill>
+            <a:schemeClr val="phClr"/>
+          </a:solidFill>
+          <a:prstDash val="solid"/>
+          <a:miter lim="800000"/>
+        </a:ln>
+        <a:ln w="19050" cap="flat" cmpd="sng" algn="ctr">
+          <a:solidFill>
+            <a:schemeClr val="phClr"/>
+          </a:solidFill>
+          <a:prstDash val="solid"/>
+          <a:miter lim="800000"/>
+        </a:ln>
+      </a:lnStyleLst>
+      <a:effectStyleLst>
+        <a:effectStyle>
+          <a:effectLst/>
+        </a:effectStyle>
+        <a:effectStyle>
+          <a:effectLst/>
+        </a:effectStyle>
+        <a:effectStyle>
+          <a:effectLst>
+            <a:outerShdw blurRad="57150" dist="19050" dir="5400000" algn="ctr" rotWithShape="0">
+              <a:srgbClr val="000000">
+                <a:alpha val="63000"/>
+              </a:srgbClr>
+            </a:outerShdw>
+          </a:effectLst>
+        </a:effectStyle>
+      </a:effectStyleLst>
+      <a:bgFillStyleLst>
+        <a:solidFill>
+          <a:schemeClr val="phClr"/>
+        </a:solidFill>
+        <a:solidFill>
+          <a:schemeClr val="phClr">
+            <a:tint val="95000"/>
+            <a:satMod val="170000"/>
+          </a:schemeClr>
+        </a:solidFill>
+        <a:gradFill rotWithShape="1">
+          <a:gsLst>
+            <a:gs pos="0">
+              <a:schemeClr val="phClr">
+                <a:tint val="93000"/>
+                <a:satMod val="150000"/>
+                <a:shade val="98000"/>
+                <a:lumMod val="102000"/>
+              </a:schemeClr>
+            </a:gs>
+            <a:gs pos="50000">
+              <a:schemeClr val="phClr">
+                <a:tint val="98000"/>
+                <a:satMod val="130000"/>
+                <a:shade val="90000"/>
+                <a:lumMod val="103000"/>
+              </a:schemeClr>
+            </a:gs>
+            <a:gs pos="100000">
+              <a:schemeClr val="phClr">
+                <a:shade val="63000"/>
+                <a:satMod val="120000"/>
+              </a:schemeClr>
+            </a:gs>
+          </a:gsLst>
+          <a:lin ang="5400000" scaled="0"/>
+        </a:gradFill>
+      </a:bgFillStyleLst>
+    </a:fmtScheme>
+  </a:themeElements>
+  <a:objectDefaults/>
+  <a:extraClrSchemeLst/>
+  <a:extLst>
+    <a:ext uri="{05A4C25C-085E-4340-85A3-A5531E510DB2}">
+      <thm15:themeFamily xmlns:thm15="http://schemas.microsoft.com/office/thememl/2012/main" name="Office Theme" id="{62F939B6-93AF-4DB8-9C6B-D6C7DFDC589F}" vid="{4A3C46E8-61CC-4603-A589-7422A47A8E4A}"/>
+    </a:ext>
+  </a:extLst>
+</a:theme>
 </file>
</xml_diff>